<commit_message>
Ajustar dos cajas de texto justas en el deck SIG360
Co-Authored-By: Claude Fable 5.1 <noreply@anthropic.com>
Claude-Session: https://claude.ai/code/session_018RzdxBRRH3HiixjfKC2d7M
</commit_message>
<xml_diff>
--- a/campaigns/sig360-202609/deck.pptx
+++ b/campaigns/sig360-202609/deck.pptx
@@ -3713,7 +3713,7 @@
                 <a:ea typeface="Calibri" pitchFamily="34" charset="-122"/>
                 <a:cs typeface="Calibri" pitchFamily="34" charset="-120"/>
               </a:rPr>
-              <a:t>Contratistas y servicios</a:t>
+              <a:t>Contratistas</a:t>
             </a:r>
             <a:endParaRPr lang="en-US" sz="1700" dirty="0"/>
           </a:p>
@@ -7295,7 +7295,7 @@
         <p:spPr>
           <a:xfrm>
             <a:off x="8229600" y="2286000"/>
-            <a:ext cx="3108960" cy="640080"/>
+            <a:ext cx="3246120" cy="640080"/>
           </a:xfrm>
           <a:prstGeom prst="rect">
             <a:avLst/>
@@ -7311,7 +7311,7 @@
               <a:buNone/>
             </a:pPr>
             <a:r>
-              <a:rPr lang="en-US" sz="3000" b="1" dirty="0">
+              <a:rPr lang="en-US" sz="2600" b="1" dirty="0">
                 <a:solidFill>
                   <a:srgbClr val="FFFFFF"/>
                 </a:solidFill>
@@ -7321,7 +7321,7 @@
               </a:rPr>
               <a:t>30 días gratis</a:t>
             </a:r>
-            <a:endParaRPr lang="en-US" sz="3000" dirty="0"/>
+            <a:endParaRPr lang="en-US" sz="2600" dirty="0"/>
           </a:p>
         </p:txBody>
       </p:sp>

</xml_diff>

<commit_message>
Unificar WhatsApp en +51 939 521 784 y retirar la oferta vencida de abril 2026
- /global, /consultoria, campaigns y tiktok-engine pasan al mismo número
  que usa la portada (portal 3D).
- /global: el distintivo de precios pasa a "30 días gratis en todos los
  planes · Sin tarjeta"; campaigns: copy sin fecha límite.
- Kit SIG360 (deck, equipo.md, brief.md) y brand-innovaq.json alineados.

Co-Authored-By: Claude Fable 5.1 <noreply@anthropic.com>
Claude-Session: https://claude.ai/code/session_018RzdxBRRH3HiixjfKC2d7M
</commit_message>
<xml_diff>
--- a/campaigns/sig360-202609/deck.pptx
+++ b/campaigns/sig360-202609/deck.pptx
@@ -1037,7 +1037,7 @@
           <a:p>
             <a:r>
               <a:rPr lang="en-US" dirty="0"/>
-              <a:t>Precios tomados de global/index.html (PRODUCTS). Confirmar vigencia de la oferta antes de publicar: el sitio aún dice "hasta abril 2026".</a:t>
+              <a:t>Precios tomados de global/index.html (PRODUCTS). La única promesa es la prueba gratis de 30 días; no hay precio de lanzamiento con fecha.</a:t>
             </a:r>
             <a:endParaRPr lang="en-US" dirty="0"/>
           </a:p>
@@ -1125,7 +1125,7 @@
           <a:p>
             <a:r>
               <a:rPr lang="en-US" dirty="0"/>
-              <a:t>Un solo CTA: la prueba de 30 días. El WhatsApp es el del portal /global (comercial).</a:t>
+              <a:t>Un solo CTA: la prueba de 30 días. WhatsApp unificado del dominio: +51 939 521 784.</a:t>
             </a:r>
             <a:endParaRPr lang="en-US" dirty="0"/>
           </a:p>
@@ -7411,7 +7411,7 @@
                 <a:ea typeface="Calibri" pitchFamily="34" charset="-122"/>
                 <a:cs typeface="Calibri" pitchFamily="34" charset="-120"/>
               </a:rPr>
-              <a:t>las 4 normas, control documentario, auditorías, IPERC dinámica, no conformidades, Bow-Tie, revisión por la dirección, canal de denuncias E2EE y 84+ plantillas ISO. Precios en dólares, sin IGV. Vigencia de la oferta de lanzamiento: por confirmar.</a:t>
+              <a:t>las 4 normas, control documentario, auditorías, IPERC dinámica, no conformidades, Bow-Tie, revisión por la dirección, canal de denuncias E2EE y 84+ plantillas ISO. Precios en dólares, sin IGV. Sin tarjeta para la prueba; sin precio de lanzamiento con fecha.</a:t>
             </a:r>
             <a:endParaRPr lang="en-US" sz="1200" dirty="0"/>
           </a:p>
@@ -7678,7 +7678,7 @@
                 <a:ea typeface="Calibri" pitchFamily="34" charset="-122"/>
                 <a:cs typeface="Calibri" pitchFamily="34" charset="-120"/>
               </a:rPr>
-              <a:t>WhatsApp  +51 900 801 059</a:t>
+              <a:t>WhatsApp  +51 939 521 784</a:t>
             </a:r>
             <a:endParaRPr lang="en-US" sz="1800" dirty="0"/>
           </a:p>

</xml_diff>